<commit_message>
feat: regenerate microsoft with LF-stable release generation
- render four voices so release-verify passes on any checkout

🎙️ - Generated by Copilot

Co-authored-by: Copilot <223556219+Copilot@users.noreply.github.com>
</commit_message>
<xml_diff>
--- a/projects/microsoft/release/outputs/deck.pptx
+++ b/projects/microsoft/release/outputs/deck.pptx
@@ -1265,7 +1265,7 @@
                   <a:srgbClr val="B6B8B6"/>
                 </a:solidFill>
               </a:rPr>
-              <a:t>microsoft-2026-04-am-michael-kokoro-onnx</a:t>
+              <a:t>microsoft-2026-05-am-michael-kokoro-onnx</a:t>
             </a:r>
           </a:p>
         </p:txBody>
@@ -2752,7 +2752,7 @@
                   <a:srgbClr val="B6B8B6"/>
                 </a:solidFill>
               </a:rPr>
-              <a:t>microsoft-2026-04-am-michael-kokoro-onnx</a:t>
+              <a:t>microsoft-2026-05-am-michael-kokoro-onnx</a:t>
             </a:r>
           </a:p>
         </p:txBody>

</xml_diff>

<commit_message>
feat: regenerate microsoft with its brand theme
- render four voices with the brand header band, palette and fonts

🎨 - Generated by Copilot

Co-authored-by: Copilot <223556219+Copilot@users.noreply.github.com>
</commit_message>
<xml_diff>
--- a/projects/microsoft/release/outputs/deck.pptx
+++ b/projects/microsoft/release/outputs/deck.pptx
@@ -18,6 +18,16 @@
     <a:defPPr>
       <a:defRPr lang="en-US"/>
     </a:defPPr>
+    <a:lvl1pPr algn="l" defTabSz="914400" marL="0" indent="0">
+      <a:defRPr sz="1800" kern="1200">
+        <a:solidFill>
+          <a:schemeClr val="tx1"/>
+        </a:solidFill>
+        <a:latin typeface="+mn-lt"/>
+        <a:ea typeface="+mn-ea"/>
+        <a:cs typeface="+mn-cs"/>
+      </a:defRPr>
+    </a:lvl1pPr>
   </p:defaultTextStyle>
 </p:presentation>
 </file>
@@ -1038,7 +1048,7 @@
     <p:bg>
       <p:bgPr>
         <a:solidFill>
-          <a:srgbClr val="101313"/>
+          <a:srgbClr val="F4F8FC"/>
         </a:solidFill>
         <a:effectLst/>
       </p:bgPr>
@@ -1052,20 +1062,20 @@
       <p:grpSpPr/>
       <p:sp>
         <p:nvSpPr>
-          <p:cNvPr id="2" name="Accent band"/>
+          <p:cNvPr id="2" name="Brand band"/>
           <p:cNvSpPr/>
           <p:nvPr/>
         </p:nvSpPr>
         <p:spPr>
           <a:xfrm>
             <a:off x="0" y="0"/>
-            <a:ext cx="12192000" cy="91440"/>
+            <a:ext cx="12192000" cy="502920"/>
           </a:xfrm>
           <a:prstGeom prst="rect">
             <a:avLst/>
           </a:prstGeom>
           <a:solidFill>
-            <a:srgbClr val="4FA3A5"/>
+            <a:srgbClr val="0E1726"/>
           </a:solidFill>
           <a:ln>
             <a:noFill/>
@@ -1074,14 +1084,36 @@
       </p:sp>
       <p:sp>
         <p:nvSpPr>
-          <p:cNvPr id="3" name="Title"/>
-          <p:cNvSpPr txBox="1"/>
-          <p:nvPr/>
-        </p:nvSpPr>
-        <p:spPr>
-          <a:xfrm>
-            <a:off x="685800" y="900000"/>
-            <a:ext cx="10820400" cy="2000000"/>
+          <p:cNvPr id="3" name="Highlight rule"/>
+          <p:cNvSpPr/>
+          <p:nvPr/>
+        </p:nvSpPr>
+        <p:spPr>
+          <a:xfrm>
+            <a:off x="0" y="502920"/>
+            <a:ext cx="12192000" cy="45720"/>
+          </a:xfrm>
+          <a:prstGeom prst="rect">
+            <a:avLst/>
+          </a:prstGeom>
+          <a:solidFill>
+            <a:srgbClr val="8AC1EB"/>
+          </a:solidFill>
+          <a:ln>
+            <a:noFill/>
+          </a:ln>
+        </p:spPr>
+      </p:sp>
+      <p:sp>
+        <p:nvSpPr>
+          <p:cNvPr id="4" name="Deck kicker"/>
+          <p:cNvSpPr txBox="1"/>
+          <p:nvPr/>
+        </p:nvSpPr>
+        <p:spPr>
+          <a:xfrm>
+            <a:off x="685800" y="0"/>
+            <a:ext cx="8400000" cy="502920"/>
           </a:xfrm>
           <a:prstGeom prst="rect">
             <a:avLst/>
@@ -1106,45 +1138,74 @@
               </a:spcAft>
             </a:pPr>
             <a:r>
-              <a:rPr lang="en-US" sz="3800" b="1">
-                <a:solidFill>
-                  <a:srgbClr val="F7F8F6"/>
-                </a:solidFill>
-              </a:rPr>
-              <a:t>Microsoft:</a:t>
-            </a:r>
-            <a:r>
-              <a:rPr lang="en-US" sz="3800" b="1">
-                <a:solidFill>
-                  <a:srgbClr val="4FA3A5"/>
-                </a:solidFill>
-              </a:rPr>
-              <a:t> map needs to the right layer</a:t>
-            </a:r>
-          </a:p>
-        </p:txBody>
-      </p:sp>
-      <p:sp>
-        <p:nvSpPr>
-          <p:cNvPr id="4" name="Summary"/>
-          <p:cNvSpPr txBox="1"/>
-          <p:nvPr/>
-        </p:nvSpPr>
-        <p:spPr>
-          <a:xfrm>
-            <a:off x="685800" y="3000000"/>
-            <a:ext cx="9600000" cy="1400000"/>
-          </a:xfrm>
-          <a:prstGeom prst="rect">
-            <a:avLst/>
-          </a:prstGeom>
-          <a:noFill/>
-          <a:ln>
-            <a:noFill/>
-          </a:ln>
-        </p:spPr>
-        <p:txBody>
-          <a:bodyPr wrap="square" lIns="182880" tIns="91440" rIns="182880" bIns="91440" anchor="t">
+              <a:rPr lang="en-US" sz="1100" b="1" cap="all" spc="120">
+                <a:solidFill>
+                  <a:srgbClr val="FFFFFF"/>
+                </a:solidFill>
+              </a:rPr>
+              <a:t>Microsoft</a:t>
+            </a:r>
+          </a:p>
+        </p:txBody>
+      </p:sp>
+      <p:sp>
+        <p:nvSpPr>
+          <p:cNvPr id="5" name="Slide number"/>
+          <p:cNvSpPr txBox="1"/>
+          <p:nvPr/>
+        </p:nvSpPr>
+        <p:spPr>
+          <a:xfrm>
+            <a:off x="9100000" y="0"/>
+            <a:ext cx="2406400" cy="502920"/>
+          </a:xfrm>
+          <a:prstGeom prst="rect">
+            <a:avLst/>
+          </a:prstGeom>
+          <a:noFill/>
+          <a:ln>
+            <a:noFill/>
+          </a:ln>
+        </p:spPr>
+        <p:txBody>
+          <a:bodyPr wrap="square" lIns="182880" tIns="91440" rIns="182880" bIns="91440" anchor="ctr">
+            <a:normAutofit/>
+          </a:bodyPr>
+          <a:lstStyle/>
+          <a:p>
+            <a:pPr algn="r"/>
+            <a:r>
+              <a:rPr lang="en-US" sz="1100" b="1" cap="all" spc="120">
+                <a:solidFill>
+                  <a:srgbClr val="BCBEC2"/>
+                </a:solidFill>
+              </a:rPr>
+              <a:t>1 / 6</a:t>
+            </a:r>
+          </a:p>
+        </p:txBody>
+      </p:sp>
+      <p:sp>
+        <p:nvSpPr>
+          <p:cNvPr id="6" name="Title"/>
+          <p:cNvSpPr txBox="1"/>
+          <p:nvPr/>
+        </p:nvSpPr>
+        <p:spPr>
+          <a:xfrm>
+            <a:off x="685800" y="1100000"/>
+            <a:ext cx="10820400" cy="2000000"/>
+          </a:xfrm>
+          <a:prstGeom prst="rect">
+            <a:avLst/>
+          </a:prstGeom>
+          <a:noFill/>
+          <a:ln>
+            <a:noFill/>
+          </a:ln>
+        </p:spPr>
+        <p:txBody>
+          <a:bodyPr wrap="square" lIns="182880" tIns="91440" rIns="182880" bIns="91440" anchor="ctr">
             <a:normAutofit/>
           </a:bodyPr>
           <a:lstStyle/>
@@ -1158,43 +1219,47 @@
               </a:spcAft>
             </a:pPr>
             <a:r>
-              <a:rPr lang="en-US" sz="1800">
-                <a:solidFill>
-                  <a:srgbClr val="B6B8B6"/>
-                </a:solidFill>
-              </a:rPr>
-              <a:t>Bottom line: Microsoft is a portfolio, not one system; first map the need to Windows, Microsoft 365, Azure or Copilot, then verify entitlements early.</a:t>
-            </a:r>
-          </a:p>
-        </p:txBody>
-      </p:sp>
-      <p:sp>
-        <p:nvSpPr>
-          <p:cNvPr id="5" name="Decision"/>
-          <p:cNvSpPr/>
-          <p:nvPr/>
-        </p:nvSpPr>
-        <p:spPr>
-          <a:xfrm>
-            <a:off x="685800" y="4500000"/>
-            <a:ext cx="10820400" cy="1000000"/>
-          </a:xfrm>
-          <a:prstGeom prst="roundRect">
-            <a:avLst>
-              <a:gd name="adj" fmla="val 9000"/>
-            </a:avLst>
-          </a:prstGeom>
-          <a:solidFill>
-            <a:srgbClr val="1A2A2A"/>
-          </a:solidFill>
-          <a:ln w="12700">
-            <a:solidFill>
-              <a:srgbClr val="4FA3A5"/>
-            </a:solidFill>
-          </a:ln>
-        </p:spPr>
-        <p:txBody>
-          <a:bodyPr wrap="square" lIns="182880" tIns="91440" rIns="182880" bIns="91440" anchor="ctr">
+              <a:rPr lang="en-US" sz="3800" b="1">
+                <a:solidFill>
+                  <a:srgbClr val="0B121E"/>
+                </a:solidFill>
+                <a:latin typeface="+mj-lt"/>
+              </a:rPr>
+              <a:t>Microsoft:</a:t>
+            </a:r>
+            <a:r>
+              <a:rPr lang="en-US" sz="3800" b="1">
+                <a:solidFill>
+                  <a:srgbClr val="006EC3"/>
+                </a:solidFill>
+                <a:latin typeface="+mj-lt"/>
+              </a:rPr>
+              <a:t> map needs to the right layer</a:t>
+            </a:r>
+          </a:p>
+        </p:txBody>
+      </p:sp>
+      <p:sp>
+        <p:nvSpPr>
+          <p:cNvPr id="7" name="Summary"/>
+          <p:cNvSpPr txBox="1"/>
+          <p:nvPr/>
+        </p:nvSpPr>
+        <p:spPr>
+          <a:xfrm>
+            <a:off x="685800" y="3150000"/>
+            <a:ext cx="9600000" cy="1400000"/>
+          </a:xfrm>
+          <a:prstGeom prst="rect">
+            <a:avLst/>
+          </a:prstGeom>
+          <a:noFill/>
+          <a:ln>
+            <a:noFill/>
+          </a:ln>
+        </p:spPr>
+        <p:txBody>
+          <a:bodyPr wrap="square" lIns="182880" tIns="91440" rIns="182880" bIns="91440" anchor="t">
             <a:normAutofit/>
           </a:bodyPr>
           <a:lstStyle/>
@@ -1208,45 +1273,43 @@
               </a:spcAft>
             </a:pPr>
             <a:r>
-              <a:rPr lang="en-US" sz="1400" b="1">
-                <a:solidFill>
-                  <a:srgbClr val="4FA3A5"/>
-                </a:solidFill>
-              </a:rPr>
-              <a:t>DECISION  </a:t>
-            </a:r>
-            <a:r>
-              <a:rPr lang="en-US" sz="2000" b="1">
-                <a:solidFill>
-                  <a:srgbClr val="F7F8F6"/>
-                </a:solidFill>
-              </a:rPr>
-              <a:t>Map needs to the right layer and confirm entitlements before committing.</a:t>
-            </a:r>
-          </a:p>
-        </p:txBody>
-      </p:sp>
-      <p:sp>
-        <p:nvSpPr>
-          <p:cNvPr id="6" name="Footer"/>
-          <p:cNvSpPr txBox="1"/>
-          <p:nvPr/>
-        </p:nvSpPr>
-        <p:spPr>
-          <a:xfrm>
-            <a:off x="685800" y="6250000"/>
-            <a:ext cx="9400000" cy="420000"/>
-          </a:xfrm>
-          <a:prstGeom prst="rect">
-            <a:avLst/>
-          </a:prstGeom>
-          <a:noFill/>
-          <a:ln>
-            <a:noFill/>
-          </a:ln>
-        </p:spPr>
-        <p:txBody>
-          <a:bodyPr wrap="square" lIns="182880" tIns="91440" rIns="182880" bIns="91440" anchor="t">
+              <a:rPr lang="en-US" sz="1800">
+                <a:solidFill>
+                  <a:srgbClr val="64686E"/>
+                </a:solidFill>
+              </a:rPr>
+              <a:t>Bottom line: Microsoft is a portfolio, not one system; first map the need to Windows, Microsoft 365, Azure or Copilot, then verify entitlements early.</a:t>
+            </a:r>
+          </a:p>
+        </p:txBody>
+      </p:sp>
+      <p:sp>
+        <p:nvSpPr>
+          <p:cNvPr id="8" name="Decision"/>
+          <p:cNvSpPr/>
+          <p:nvPr/>
+        </p:nvSpPr>
+        <p:spPr>
+          <a:xfrm>
+            <a:off x="685800" y="4650000"/>
+            <a:ext cx="10820400" cy="1000000"/>
+          </a:xfrm>
+          <a:prstGeom prst="roundRect">
+            <a:avLst>
+              <a:gd name="adj" fmla="val 6000"/>
+            </a:avLst>
+          </a:prstGeom>
+          <a:solidFill>
+            <a:srgbClr val="EDF6FC"/>
+          </a:solidFill>
+          <a:ln w="12700">
+            <a:solidFill>
+              <a:srgbClr val="567892"/>
+            </a:solidFill>
+          </a:ln>
+        </p:spPr>
+        <p:txBody>
+          <a:bodyPr wrap="square" lIns="182880" tIns="91440" rIns="182880" bIns="91440" anchor="ctr">
             <a:normAutofit/>
           </a:bodyPr>
           <a:lstStyle/>
@@ -1260,26 +1323,34 @@
               </a:spcAft>
             </a:pPr>
             <a:r>
-              <a:rPr lang="en-US" sz="1000">
-                <a:solidFill>
-                  <a:srgbClr val="B6B8B6"/>
-                </a:solidFill>
-              </a:rPr>
-              <a:t>microsoft-2026-05-am-michael-kokoro-onnx</a:t>
-            </a:r>
-          </a:p>
-        </p:txBody>
-      </p:sp>
-      <p:sp>
-        <p:nvSpPr>
-          <p:cNvPr id="7" name="Slide number"/>
-          <p:cNvSpPr txBox="1"/>
-          <p:nvPr/>
-        </p:nvSpPr>
-        <p:spPr>
-          <a:xfrm>
-            <a:off x="10100000" y="6250000"/>
-            <a:ext cx="1400000" cy="420000"/>
+              <a:rPr lang="en-US" sz="1400" b="1">
+                <a:solidFill>
+                  <a:srgbClr val="006EC3"/>
+                </a:solidFill>
+              </a:rPr>
+              <a:t>DECISION  </a:t>
+            </a:r>
+            <a:r>
+              <a:rPr lang="en-US" sz="2000" b="1">
+                <a:solidFill>
+                  <a:srgbClr val="0B121E"/>
+                </a:solidFill>
+              </a:rPr>
+              <a:t>Map needs to the right layer and confirm entitlements before committing.</a:t>
+            </a:r>
+          </a:p>
+        </p:txBody>
+      </p:sp>
+      <p:sp>
+        <p:nvSpPr>
+          <p:cNvPr id="9" name="Footer"/>
+          <p:cNvSpPr txBox="1"/>
+          <p:nvPr/>
+        </p:nvSpPr>
+        <p:spPr>
+          <a:xfrm>
+            <a:off x="685800" y="6250000"/>
+            <a:ext cx="10820400" cy="420000"/>
           </a:xfrm>
           <a:prstGeom prst="rect">
             <a:avLst/>
@@ -1295,14 +1366,21 @@
           </a:bodyPr>
           <a:lstStyle/>
           <a:p>
-            <a:pPr algn="r"/>
+            <a:pPr algn="l">
+              <a:lnSpc>
+                <a:spcPct val="105000"/>
+              </a:lnSpc>
+              <a:spcAft>
+                <a:spcPts val="0"/>
+              </a:spcAft>
+            </a:pPr>
             <a:r>
               <a:rPr lang="en-US" sz="1000">
                 <a:solidFill>
-                  <a:srgbClr val="B6B8B6"/>
-                </a:solidFill>
-              </a:rPr>
-              <a:t>1 / 6</a:t>
+                  <a:srgbClr val="64686E"/>
+                </a:solidFill>
+              </a:rPr>
+              <a:t>microsoft-2026-06-am-michael-kokoro-onnx</a:t>
             </a:r>
           </a:p>
         </p:txBody>
@@ -1321,7 +1399,7 @@
     <p:bg>
       <p:bgPr>
         <a:solidFill>
-          <a:srgbClr val="101313"/>
+          <a:srgbClr val="F4F8FC"/>
         </a:solidFill>
         <a:effectLst/>
       </p:bgPr>
@@ -1335,20 +1413,20 @@
       <p:grpSpPr/>
       <p:sp>
         <p:nvSpPr>
-          <p:cNvPr id="2" name="Accent band"/>
+          <p:cNvPr id="2" name="Brand band"/>
           <p:cNvSpPr/>
           <p:nvPr/>
         </p:nvSpPr>
         <p:spPr>
           <a:xfrm>
             <a:off x="0" y="0"/>
-            <a:ext cx="12192000" cy="91440"/>
+            <a:ext cx="12192000" cy="502920"/>
           </a:xfrm>
           <a:prstGeom prst="rect">
             <a:avLst/>
           </a:prstGeom>
           <a:solidFill>
-            <a:srgbClr val="4FA3A5"/>
+            <a:srgbClr val="0E1726"/>
           </a:solidFill>
           <a:ln>
             <a:noFill/>
@@ -1357,14 +1435,36 @@
       </p:sp>
       <p:sp>
         <p:nvSpPr>
-          <p:cNvPr id="3" name="Title"/>
-          <p:cNvSpPr txBox="1"/>
-          <p:nvPr/>
-        </p:nvSpPr>
-        <p:spPr>
-          <a:xfrm>
-            <a:off x="685800" y="420000"/>
-            <a:ext cx="10820400" cy="1150000"/>
+          <p:cNvPr id="3" name="Highlight rule"/>
+          <p:cNvSpPr/>
+          <p:nvPr/>
+        </p:nvSpPr>
+        <p:spPr>
+          <a:xfrm>
+            <a:off x="0" y="502920"/>
+            <a:ext cx="12192000" cy="45720"/>
+          </a:xfrm>
+          <a:prstGeom prst="rect">
+            <a:avLst/>
+          </a:prstGeom>
+          <a:solidFill>
+            <a:srgbClr val="8AC1EB"/>
+          </a:solidFill>
+          <a:ln>
+            <a:noFill/>
+          </a:ln>
+        </p:spPr>
+      </p:sp>
+      <p:sp>
+        <p:nvSpPr>
+          <p:cNvPr id="4" name="Deck kicker"/>
+          <p:cNvSpPr txBox="1"/>
+          <p:nvPr/>
+        </p:nvSpPr>
+        <p:spPr>
+          <a:xfrm>
+            <a:off x="685800" y="0"/>
+            <a:ext cx="8400000" cy="502920"/>
           </a:xfrm>
           <a:prstGeom prst="rect">
             <a:avLst/>
@@ -1389,45 +1489,74 @@
               </a:spcAft>
             </a:pPr>
             <a:r>
-              <a:rPr lang="en-US" sz="2900" b="1">
-                <a:solidFill>
-                  <a:srgbClr val="F7F8F6"/>
-                </a:solidFill>
-              </a:rPr>
-              <a:t>1.</a:t>
-            </a:r>
-            <a:r>
-              <a:rPr lang="en-US" sz="2900" b="1">
-                <a:solidFill>
-                  <a:srgbClr val="4FA3A5"/>
-                </a:solidFill>
-              </a:rPr>
-              <a:t> Windows is the PC layer</a:t>
-            </a:r>
-          </a:p>
-        </p:txBody>
-      </p:sp>
-      <p:sp>
-        <p:nvSpPr>
-          <p:cNvPr id="4" name="Body"/>
-          <p:cNvSpPr txBox="1"/>
-          <p:nvPr/>
-        </p:nvSpPr>
-        <p:spPr>
-          <a:xfrm>
-            <a:off x="685800" y="1750000"/>
-            <a:ext cx="3900000" cy="3900000"/>
-          </a:xfrm>
-          <a:prstGeom prst="rect">
-            <a:avLst/>
-          </a:prstGeom>
-          <a:noFill/>
-          <a:ln>
-            <a:noFill/>
-          </a:ln>
-        </p:spPr>
-        <p:txBody>
-          <a:bodyPr wrap="square" lIns="182880" tIns="91440" rIns="182880" bIns="91440" anchor="t">
+              <a:rPr lang="en-US" sz="1100" b="1" cap="all" spc="120">
+                <a:solidFill>
+                  <a:srgbClr val="FFFFFF"/>
+                </a:solidFill>
+              </a:rPr>
+              <a:t>Microsoft</a:t>
+            </a:r>
+          </a:p>
+        </p:txBody>
+      </p:sp>
+      <p:sp>
+        <p:nvSpPr>
+          <p:cNvPr id="5" name="Slide number"/>
+          <p:cNvSpPr txBox="1"/>
+          <p:nvPr/>
+        </p:nvSpPr>
+        <p:spPr>
+          <a:xfrm>
+            <a:off x="9100000" y="0"/>
+            <a:ext cx="2406400" cy="502920"/>
+          </a:xfrm>
+          <a:prstGeom prst="rect">
+            <a:avLst/>
+          </a:prstGeom>
+          <a:noFill/>
+          <a:ln>
+            <a:noFill/>
+          </a:ln>
+        </p:spPr>
+        <p:txBody>
+          <a:bodyPr wrap="square" lIns="182880" tIns="91440" rIns="182880" bIns="91440" anchor="ctr">
+            <a:normAutofit/>
+          </a:bodyPr>
+          <a:lstStyle/>
+          <a:p>
+            <a:pPr algn="r"/>
+            <a:r>
+              <a:rPr lang="en-US" sz="1100" b="1" cap="all" spc="120">
+                <a:solidFill>
+                  <a:srgbClr val="BCBEC2"/>
+                </a:solidFill>
+              </a:rPr>
+              <a:t>2 / 6</a:t>
+            </a:r>
+          </a:p>
+        </p:txBody>
+      </p:sp>
+      <p:sp>
+        <p:nvSpPr>
+          <p:cNvPr id="6" name="Title"/>
+          <p:cNvSpPr txBox="1"/>
+          <p:nvPr/>
+        </p:nvSpPr>
+        <p:spPr>
+          <a:xfrm>
+            <a:off x="685800" y="700000"/>
+            <a:ext cx="10820400" cy="1150000"/>
+          </a:xfrm>
+          <a:prstGeom prst="rect">
+            <a:avLst/>
+          </a:prstGeom>
+          <a:noFill/>
+          <a:ln>
+            <a:noFill/>
+          </a:ln>
+        </p:spPr>
+        <p:txBody>
+          <a:bodyPr wrap="square" lIns="182880" tIns="91440" rIns="182880" bIns="91440" anchor="ctr">
             <a:normAutofit/>
           </a:bodyPr>
           <a:lstStyle/>
@@ -1441,77 +1570,36 @@
               </a:spcAft>
             </a:pPr>
             <a:r>
-              <a:rPr lang="en-US" sz="2400">
-                <a:solidFill>
-                  <a:srgbClr val="F7F8F6"/>
-                </a:solidFill>
-              </a:rPr>
-              <a:t>Start with Windows when the decision is the PC experience: devices, desktop, apps and user productivity. It anchors the endpoint for users, not every cloud service.</a:t>
-            </a:r>
-          </a:p>
-        </p:txBody>
-      </p:sp>
-      <p:sp>
-        <p:nvSpPr>
-          <p:cNvPr id="5" name="Accent rule"/>
-          <p:cNvSpPr/>
-          <p:nvPr/>
-        </p:nvSpPr>
-        <p:spPr>
-          <a:xfrm>
-            <a:off x="548640" y="1800000"/>
-            <a:ext cx="45720" cy="3800000"/>
-          </a:xfrm>
-          <a:prstGeom prst="rect">
-            <a:avLst/>
-          </a:prstGeom>
-          <a:solidFill>
-            <a:srgbClr val="4FA3A5"/>
-          </a:solidFill>
-          <a:ln>
-            <a:noFill/>
-          </a:ln>
-        </p:spPr>
-      </p:sp>
-      <p:pic>
-        <p:nvPicPr>
-          <p:cNvPr id="6" name="Asset visual-windows-layer" descr="The decision map starts with the user endpoint, then separates work services, app services and AI assistance. (mermaid diagram)"/>
-          <p:cNvPicPr>
-            <a:picLocks noChangeAspect="1"/>
-          </p:cNvPicPr>
-          <p:nvPr/>
-        </p:nvPicPr>
-        <p:blipFill>
-          <a:blip r:embed="rIdImage1"/>
-          <a:stretch>
-            <a:fillRect/>
-          </a:stretch>
-        </p:blipFill>
-        <p:spPr>
-          <a:xfrm>
-            <a:off x="5000000" y="2021875"/>
-            <a:ext cx="6500000" cy="3656250"/>
-          </a:xfrm>
-          <a:prstGeom prst="rect">
-            <a:avLst/>
-          </a:prstGeom>
-          <a:ln>
-            <a:solidFill>
-              <a:srgbClr val="D9D9D9"/>
-            </a:solidFill>
-          </a:ln>
-        </p:spPr>
-      </p:pic>
-      <p:sp>
-        <p:nvSpPr>
-          <p:cNvPr id="7" name="Footer"/>
-          <p:cNvSpPr txBox="1"/>
-          <p:nvPr/>
-        </p:nvSpPr>
-        <p:spPr>
-          <a:xfrm>
-            <a:off x="685800" y="6250000"/>
-            <a:ext cx="9400000" cy="420000"/>
+              <a:rPr lang="en-US" sz="2900" b="1">
+                <a:solidFill>
+                  <a:srgbClr val="0B121E"/>
+                </a:solidFill>
+                <a:latin typeface="+mj-lt"/>
+              </a:rPr>
+              <a:t>1.</a:t>
+            </a:r>
+            <a:r>
+              <a:rPr lang="en-US" sz="2900" b="1">
+                <a:solidFill>
+                  <a:srgbClr val="006EC3"/>
+                </a:solidFill>
+                <a:latin typeface="+mj-lt"/>
+              </a:rPr>
+              <a:t> Windows is the PC layer</a:t>
+            </a:r>
+          </a:p>
+        </p:txBody>
+      </p:sp>
+      <p:sp>
+        <p:nvSpPr>
+          <p:cNvPr id="7" name="Body"/>
+          <p:cNvSpPr txBox="1"/>
+          <p:nvPr/>
+        </p:nvSpPr>
+        <p:spPr>
+          <a:xfrm>
+            <a:off x="685800" y="1950000"/>
+            <a:ext cx="3900000" cy="3900000"/>
           </a:xfrm>
           <a:prstGeom prst="rect">
             <a:avLst/>
@@ -1536,26 +1624,77 @@
               </a:spcAft>
             </a:pPr>
             <a:r>
-              <a:rPr lang="en-US" sz="1000">
-                <a:solidFill>
-                  <a:srgbClr val="B6B8B6"/>
-                </a:solidFill>
-              </a:rPr>
-              <a:t>Sources: Windows 11 overview for administrators | Microsoft Learn  ·  Microsoft 365 for enterprise overview - Microsoft 365 Enterprise | Microsoft Learn  ·  Azure documentation | Microsoft Learn  ·  +1 more</a:t>
-            </a:r>
-          </a:p>
-        </p:txBody>
-      </p:sp>
-      <p:sp>
-        <p:nvSpPr>
-          <p:cNvPr id="8" name="Slide number"/>
-          <p:cNvSpPr txBox="1"/>
-          <p:nvPr/>
-        </p:nvSpPr>
-        <p:spPr>
-          <a:xfrm>
-            <a:off x="10100000" y="6250000"/>
-            <a:ext cx="1400000" cy="420000"/>
+              <a:rPr lang="en-US" sz="2400">
+                <a:solidFill>
+                  <a:srgbClr val="0B121E"/>
+                </a:solidFill>
+              </a:rPr>
+              <a:t>Start with Windows when the decision is the PC experience: devices, desktop, apps and user productivity. It anchors the endpoint for users, not every cloud service.</a:t>
+            </a:r>
+          </a:p>
+        </p:txBody>
+      </p:sp>
+      <p:sp>
+        <p:nvSpPr>
+          <p:cNvPr id="8" name="Accent rule"/>
+          <p:cNvSpPr/>
+          <p:nvPr/>
+        </p:nvSpPr>
+        <p:spPr>
+          <a:xfrm>
+            <a:off x="548640" y="2000000"/>
+            <a:ext cx="45720" cy="3800000"/>
+          </a:xfrm>
+          <a:prstGeom prst="rect">
+            <a:avLst/>
+          </a:prstGeom>
+          <a:solidFill>
+            <a:srgbClr val="006EC3"/>
+          </a:solidFill>
+          <a:ln>
+            <a:noFill/>
+          </a:ln>
+        </p:spPr>
+      </p:sp>
+      <p:pic>
+        <p:nvPicPr>
+          <p:cNvPr id="9" name="Asset visual-windows-layer" descr="The decision map starts with the user endpoint, then separates work services, app services and AI assistance. (mermaid diagram)"/>
+          <p:cNvPicPr>
+            <a:picLocks noChangeAspect="1"/>
+          </p:cNvPicPr>
+          <p:nvPr/>
+        </p:nvPicPr>
+        <p:blipFill>
+          <a:blip r:embed="rIdImage1"/>
+          <a:stretch>
+            <a:fillRect/>
+          </a:stretch>
+        </p:blipFill>
+        <p:spPr>
+          <a:xfrm>
+            <a:off x="5000000" y="2221875"/>
+            <a:ext cx="6500000" cy="3656250"/>
+          </a:xfrm>
+          <a:prstGeom prst="rect">
+            <a:avLst/>
+          </a:prstGeom>
+          <a:ln>
+            <a:solidFill>
+              <a:srgbClr val="D9D9D9"/>
+            </a:solidFill>
+          </a:ln>
+        </p:spPr>
+      </p:pic>
+      <p:sp>
+        <p:nvSpPr>
+          <p:cNvPr id="10" name="Footer"/>
+          <p:cNvSpPr txBox="1"/>
+          <p:nvPr/>
+        </p:nvSpPr>
+        <p:spPr>
+          <a:xfrm>
+            <a:off x="685800" y="6250000"/>
+            <a:ext cx="10820400" cy="420000"/>
           </a:xfrm>
           <a:prstGeom prst="rect">
             <a:avLst/>
@@ -1571,14 +1710,21 @@
           </a:bodyPr>
           <a:lstStyle/>
           <a:p>
-            <a:pPr algn="r"/>
+            <a:pPr algn="l">
+              <a:lnSpc>
+                <a:spcPct val="105000"/>
+              </a:lnSpc>
+              <a:spcAft>
+                <a:spcPts val="0"/>
+              </a:spcAft>
+            </a:pPr>
             <a:r>
               <a:rPr lang="en-US" sz="1000">
                 <a:solidFill>
-                  <a:srgbClr val="B6B8B6"/>
-                </a:solidFill>
-              </a:rPr>
-              <a:t>2 / 6</a:t>
+                  <a:srgbClr val="64686E"/>
+                </a:solidFill>
+              </a:rPr>
+              <a:t>Sources: Windows 11 overview for administrators | Microsoft Learn  ·  Microsoft 365 for enterprise overview - Microsoft 365 Enterprise | Microsoft Learn  ·  Azure documentation | Microsoft Learn  ·  +1 more</a:t>
             </a:r>
           </a:p>
         </p:txBody>
@@ -1597,7 +1743,7 @@
     <p:bg>
       <p:bgPr>
         <a:solidFill>
-          <a:srgbClr val="101313"/>
+          <a:srgbClr val="F4F8FC"/>
         </a:solidFill>
         <a:effectLst/>
       </p:bgPr>
@@ -1611,20 +1757,20 @@
       <p:grpSpPr/>
       <p:sp>
         <p:nvSpPr>
-          <p:cNvPr id="2" name="Accent band"/>
+          <p:cNvPr id="2" name="Brand band"/>
           <p:cNvSpPr/>
           <p:nvPr/>
         </p:nvSpPr>
         <p:spPr>
           <a:xfrm>
             <a:off x="0" y="0"/>
-            <a:ext cx="12192000" cy="91440"/>
+            <a:ext cx="12192000" cy="502920"/>
           </a:xfrm>
           <a:prstGeom prst="rect">
             <a:avLst/>
           </a:prstGeom>
           <a:solidFill>
-            <a:srgbClr val="4FA3A5"/>
+            <a:srgbClr val="0E1726"/>
           </a:solidFill>
           <a:ln>
             <a:noFill/>
@@ -1633,14 +1779,36 @@
       </p:sp>
       <p:sp>
         <p:nvSpPr>
-          <p:cNvPr id="3" name="Title"/>
-          <p:cNvSpPr txBox="1"/>
-          <p:nvPr/>
-        </p:nvSpPr>
-        <p:spPr>
-          <a:xfrm>
-            <a:off x="685800" y="420000"/>
-            <a:ext cx="10820400" cy="1150000"/>
+          <p:cNvPr id="3" name="Highlight rule"/>
+          <p:cNvSpPr/>
+          <p:nvPr/>
+        </p:nvSpPr>
+        <p:spPr>
+          <a:xfrm>
+            <a:off x="0" y="502920"/>
+            <a:ext cx="12192000" cy="45720"/>
+          </a:xfrm>
+          <a:prstGeom prst="rect">
+            <a:avLst/>
+          </a:prstGeom>
+          <a:solidFill>
+            <a:srgbClr val="8AC1EB"/>
+          </a:solidFill>
+          <a:ln>
+            <a:noFill/>
+          </a:ln>
+        </p:spPr>
+      </p:sp>
+      <p:sp>
+        <p:nvSpPr>
+          <p:cNvPr id="4" name="Deck kicker"/>
+          <p:cNvSpPr txBox="1"/>
+          <p:nvPr/>
+        </p:nvSpPr>
+        <p:spPr>
+          <a:xfrm>
+            <a:off x="685800" y="0"/>
+            <a:ext cx="8400000" cy="502920"/>
           </a:xfrm>
           <a:prstGeom prst="rect">
             <a:avLst/>
@@ -1665,45 +1833,74 @@
               </a:spcAft>
             </a:pPr>
             <a:r>
-              <a:rPr lang="en-US" sz="2900" b="1">
-                <a:solidFill>
-                  <a:srgbClr val="F7F8F6"/>
-                </a:solidFill>
-              </a:rPr>
-              <a:t>2.</a:t>
-            </a:r>
-            <a:r>
-              <a:rPr lang="en-US" sz="2900" b="1">
-                <a:solidFill>
-                  <a:srgbClr val="4FA3A5"/>
-                </a:solidFill>
-              </a:rPr>
-              <a:t> Microsoft 365 is work</a:t>
-            </a:r>
-          </a:p>
-        </p:txBody>
-      </p:sp>
-      <p:sp>
-        <p:nvSpPr>
-          <p:cNvPr id="4" name="Body"/>
-          <p:cNvSpPr txBox="1"/>
-          <p:nvPr/>
-        </p:nvSpPr>
-        <p:spPr>
-          <a:xfrm>
-            <a:off x="685800" y="1750000"/>
-            <a:ext cx="3900000" cy="3900000"/>
-          </a:xfrm>
-          <a:prstGeom prst="rect">
-            <a:avLst/>
-          </a:prstGeom>
-          <a:noFill/>
-          <a:ln>
-            <a:noFill/>
-          </a:ln>
-        </p:spPr>
-        <p:txBody>
-          <a:bodyPr wrap="square" lIns="182880" tIns="91440" rIns="182880" bIns="91440" anchor="t">
+              <a:rPr lang="en-US" sz="1100" b="1" cap="all" spc="120">
+                <a:solidFill>
+                  <a:srgbClr val="FFFFFF"/>
+                </a:solidFill>
+              </a:rPr>
+              <a:t>Microsoft</a:t>
+            </a:r>
+          </a:p>
+        </p:txBody>
+      </p:sp>
+      <p:sp>
+        <p:nvSpPr>
+          <p:cNvPr id="5" name="Slide number"/>
+          <p:cNvSpPr txBox="1"/>
+          <p:nvPr/>
+        </p:nvSpPr>
+        <p:spPr>
+          <a:xfrm>
+            <a:off x="9100000" y="0"/>
+            <a:ext cx="2406400" cy="502920"/>
+          </a:xfrm>
+          <a:prstGeom prst="rect">
+            <a:avLst/>
+          </a:prstGeom>
+          <a:noFill/>
+          <a:ln>
+            <a:noFill/>
+          </a:ln>
+        </p:spPr>
+        <p:txBody>
+          <a:bodyPr wrap="square" lIns="182880" tIns="91440" rIns="182880" bIns="91440" anchor="ctr">
+            <a:normAutofit/>
+          </a:bodyPr>
+          <a:lstStyle/>
+          <a:p>
+            <a:pPr algn="r"/>
+            <a:r>
+              <a:rPr lang="en-US" sz="1100" b="1" cap="all" spc="120">
+                <a:solidFill>
+                  <a:srgbClr val="BCBEC2"/>
+                </a:solidFill>
+              </a:rPr>
+              <a:t>3 / 6</a:t>
+            </a:r>
+          </a:p>
+        </p:txBody>
+      </p:sp>
+      <p:sp>
+        <p:nvSpPr>
+          <p:cNvPr id="6" name="Title"/>
+          <p:cNvSpPr txBox="1"/>
+          <p:nvPr/>
+        </p:nvSpPr>
+        <p:spPr>
+          <a:xfrm>
+            <a:off x="685800" y="700000"/>
+            <a:ext cx="10820400" cy="1150000"/>
+          </a:xfrm>
+          <a:prstGeom prst="rect">
+            <a:avLst/>
+          </a:prstGeom>
+          <a:noFill/>
+          <a:ln>
+            <a:noFill/>
+          </a:ln>
+        </p:spPr>
+        <p:txBody>
+          <a:bodyPr wrap="square" lIns="182880" tIns="91440" rIns="182880" bIns="91440" anchor="ctr">
             <a:normAutofit/>
           </a:bodyPr>
           <a:lstStyle/>
@@ -1717,77 +1914,36 @@
               </a:spcAft>
             </a:pPr>
             <a:r>
-              <a:rPr lang="en-US" sz="2400">
-                <a:solidFill>
-                  <a:srgbClr val="F7F8F6"/>
-                </a:solidFill>
-              </a:rPr>
-              <a:t>Use Microsoft 365 when the need is everyday work: Office apps, email, files, meetings, sharing and collaboration. It packages work services, not custom infrastructure.</a:t>
-            </a:r>
-          </a:p>
-        </p:txBody>
-      </p:sp>
-      <p:sp>
-        <p:nvSpPr>
-          <p:cNvPr id="5" name="Accent rule"/>
-          <p:cNvSpPr/>
-          <p:nvPr/>
-        </p:nvSpPr>
-        <p:spPr>
-          <a:xfrm>
-            <a:off x="548640" y="1800000"/>
-            <a:ext cx="45720" cy="3800000"/>
-          </a:xfrm>
-          <a:prstGeom prst="rect">
-            <a:avLst/>
-          </a:prstGeom>
-          <a:solidFill>
-            <a:srgbClr val="4FA3A5"/>
-          </a:solidFill>
-          <a:ln>
-            <a:noFill/>
-          </a:ln>
-        </p:spPr>
-      </p:sp>
-      <p:pic>
-        <p:nvPicPr>
-          <p:cNvPr id="6" name="Asset visual-work-layer" descr="Microsoft 365 groups common work capabilities into a productivity-services layer. (excalidraw diagram)"/>
-          <p:cNvPicPr>
-            <a:picLocks noChangeAspect="1"/>
-          </p:cNvPicPr>
-          <p:nvPr/>
-        </p:nvPicPr>
-        <p:blipFill>
-          <a:blip r:embed="rIdImage1"/>
-          <a:stretch>
-            <a:fillRect/>
-          </a:stretch>
-        </p:blipFill>
-        <p:spPr>
-          <a:xfrm>
-            <a:off x="5000000" y="2021875"/>
-            <a:ext cx="6500000" cy="3656250"/>
-          </a:xfrm>
-          <a:prstGeom prst="rect">
-            <a:avLst/>
-          </a:prstGeom>
-          <a:ln>
-            <a:solidFill>
-              <a:srgbClr val="D9D9D9"/>
-            </a:solidFill>
-          </a:ln>
-        </p:spPr>
-      </p:pic>
-      <p:sp>
-        <p:nvSpPr>
-          <p:cNvPr id="7" name="Footer"/>
-          <p:cNvSpPr txBox="1"/>
-          <p:nvPr/>
-        </p:nvSpPr>
-        <p:spPr>
-          <a:xfrm>
-            <a:off x="685800" y="6250000"/>
-            <a:ext cx="9400000" cy="420000"/>
+              <a:rPr lang="en-US" sz="2900" b="1">
+                <a:solidFill>
+                  <a:srgbClr val="0B121E"/>
+                </a:solidFill>
+                <a:latin typeface="+mj-lt"/>
+              </a:rPr>
+              <a:t>2.</a:t>
+            </a:r>
+            <a:r>
+              <a:rPr lang="en-US" sz="2900" b="1">
+                <a:solidFill>
+                  <a:srgbClr val="006EC3"/>
+                </a:solidFill>
+                <a:latin typeface="+mj-lt"/>
+              </a:rPr>
+              <a:t> Microsoft 365 is work</a:t>
+            </a:r>
+          </a:p>
+        </p:txBody>
+      </p:sp>
+      <p:sp>
+        <p:nvSpPr>
+          <p:cNvPr id="7" name="Body"/>
+          <p:cNvSpPr txBox="1"/>
+          <p:nvPr/>
+        </p:nvSpPr>
+        <p:spPr>
+          <a:xfrm>
+            <a:off x="685800" y="1950000"/>
+            <a:ext cx="3900000" cy="3900000"/>
           </a:xfrm>
           <a:prstGeom prst="rect">
             <a:avLst/>
@@ -1812,26 +1968,77 @@
               </a:spcAft>
             </a:pPr>
             <a:r>
-              <a:rPr lang="en-US" sz="1000">
-                <a:solidFill>
-                  <a:srgbClr val="B6B8B6"/>
-                </a:solidFill>
-              </a:rPr>
-              <a:t>Sources: Microsoft 365 for enterprise overview - Microsoft 365 Enterprise | Microsoft Learn  ·  Windows 11 overview for administrators | Microsoft Learn  ·  Azure documentation | Microsoft Learn  ·  +1 more</a:t>
-            </a:r>
-          </a:p>
-        </p:txBody>
-      </p:sp>
-      <p:sp>
-        <p:nvSpPr>
-          <p:cNvPr id="8" name="Slide number"/>
-          <p:cNvSpPr txBox="1"/>
-          <p:nvPr/>
-        </p:nvSpPr>
-        <p:spPr>
-          <a:xfrm>
-            <a:off x="10100000" y="6250000"/>
-            <a:ext cx="1400000" cy="420000"/>
+              <a:rPr lang="en-US" sz="2400">
+                <a:solidFill>
+                  <a:srgbClr val="0B121E"/>
+                </a:solidFill>
+              </a:rPr>
+              <a:t>Use Microsoft 365 when the need is everyday work: Office apps, email, files, meetings, sharing and collaboration. It packages work services, not custom infrastructure.</a:t>
+            </a:r>
+          </a:p>
+        </p:txBody>
+      </p:sp>
+      <p:sp>
+        <p:nvSpPr>
+          <p:cNvPr id="8" name="Accent rule"/>
+          <p:cNvSpPr/>
+          <p:nvPr/>
+        </p:nvSpPr>
+        <p:spPr>
+          <a:xfrm>
+            <a:off x="548640" y="2000000"/>
+            <a:ext cx="45720" cy="3800000"/>
+          </a:xfrm>
+          <a:prstGeom prst="rect">
+            <a:avLst/>
+          </a:prstGeom>
+          <a:solidFill>
+            <a:srgbClr val="006EC3"/>
+          </a:solidFill>
+          <a:ln>
+            <a:noFill/>
+          </a:ln>
+        </p:spPr>
+      </p:sp>
+      <p:pic>
+        <p:nvPicPr>
+          <p:cNvPr id="9" name="Asset visual-work-layer" descr="Microsoft 365 groups common work capabilities into a productivity-services layer. (excalidraw diagram)"/>
+          <p:cNvPicPr>
+            <a:picLocks noChangeAspect="1"/>
+          </p:cNvPicPr>
+          <p:nvPr/>
+        </p:nvPicPr>
+        <p:blipFill>
+          <a:blip r:embed="rIdImage1"/>
+          <a:stretch>
+            <a:fillRect/>
+          </a:stretch>
+        </p:blipFill>
+        <p:spPr>
+          <a:xfrm>
+            <a:off x="5000000" y="2221875"/>
+            <a:ext cx="6500000" cy="3656250"/>
+          </a:xfrm>
+          <a:prstGeom prst="rect">
+            <a:avLst/>
+          </a:prstGeom>
+          <a:ln>
+            <a:solidFill>
+              <a:srgbClr val="D9D9D9"/>
+            </a:solidFill>
+          </a:ln>
+        </p:spPr>
+      </p:pic>
+      <p:sp>
+        <p:nvSpPr>
+          <p:cNvPr id="10" name="Footer"/>
+          <p:cNvSpPr txBox="1"/>
+          <p:nvPr/>
+        </p:nvSpPr>
+        <p:spPr>
+          <a:xfrm>
+            <a:off x="685800" y="6250000"/>
+            <a:ext cx="10820400" cy="420000"/>
           </a:xfrm>
           <a:prstGeom prst="rect">
             <a:avLst/>
@@ -1847,14 +2054,21 @@
           </a:bodyPr>
           <a:lstStyle/>
           <a:p>
-            <a:pPr algn="r"/>
+            <a:pPr algn="l">
+              <a:lnSpc>
+                <a:spcPct val="105000"/>
+              </a:lnSpc>
+              <a:spcAft>
+                <a:spcPts val="0"/>
+              </a:spcAft>
+            </a:pPr>
             <a:r>
               <a:rPr lang="en-US" sz="1000">
                 <a:solidFill>
-                  <a:srgbClr val="B6B8B6"/>
-                </a:solidFill>
-              </a:rPr>
-              <a:t>3 / 6</a:t>
+                  <a:srgbClr val="64686E"/>
+                </a:solidFill>
+              </a:rPr>
+              <a:t>Sources: Microsoft 365 for enterprise overview - Microsoft 365 Enterprise | Microsoft Learn  ·  Windows 11 overview for administrators | Microsoft Learn  ·  Azure documentation | Microsoft Learn  ·  +1 more</a:t>
             </a:r>
           </a:p>
         </p:txBody>
@@ -1873,7 +2087,7 @@
     <p:bg>
       <p:bgPr>
         <a:solidFill>
-          <a:srgbClr val="101313"/>
+          <a:srgbClr val="F4F8FC"/>
         </a:solidFill>
         <a:effectLst/>
       </p:bgPr>
@@ -1887,20 +2101,20 @@
       <p:grpSpPr/>
       <p:sp>
         <p:nvSpPr>
-          <p:cNvPr id="2" name="Accent band"/>
+          <p:cNvPr id="2" name="Brand band"/>
           <p:cNvSpPr/>
           <p:nvPr/>
         </p:nvSpPr>
         <p:spPr>
           <a:xfrm>
             <a:off x="0" y="0"/>
-            <a:ext cx="12192000" cy="91440"/>
+            <a:ext cx="12192000" cy="502920"/>
           </a:xfrm>
           <a:prstGeom prst="rect">
             <a:avLst/>
           </a:prstGeom>
           <a:solidFill>
-            <a:srgbClr val="4FA3A5"/>
+            <a:srgbClr val="0E1726"/>
           </a:solidFill>
           <a:ln>
             <a:noFill/>
@@ -1909,14 +2123,36 @@
       </p:sp>
       <p:sp>
         <p:nvSpPr>
-          <p:cNvPr id="3" name="Title"/>
-          <p:cNvSpPr txBox="1"/>
-          <p:nvPr/>
-        </p:nvSpPr>
-        <p:spPr>
-          <a:xfrm>
-            <a:off x="685800" y="420000"/>
-            <a:ext cx="10820400" cy="1150000"/>
+          <p:cNvPr id="3" name="Highlight rule"/>
+          <p:cNvSpPr/>
+          <p:nvPr/>
+        </p:nvSpPr>
+        <p:spPr>
+          <a:xfrm>
+            <a:off x="0" y="502920"/>
+            <a:ext cx="12192000" cy="45720"/>
+          </a:xfrm>
+          <a:prstGeom prst="rect">
+            <a:avLst/>
+          </a:prstGeom>
+          <a:solidFill>
+            <a:srgbClr val="8AC1EB"/>
+          </a:solidFill>
+          <a:ln>
+            <a:noFill/>
+          </a:ln>
+        </p:spPr>
+      </p:sp>
+      <p:sp>
+        <p:nvSpPr>
+          <p:cNvPr id="4" name="Deck kicker"/>
+          <p:cNvSpPr txBox="1"/>
+          <p:nvPr/>
+        </p:nvSpPr>
+        <p:spPr>
+          <a:xfrm>
+            <a:off x="685800" y="0"/>
+            <a:ext cx="8400000" cy="502920"/>
           </a:xfrm>
           <a:prstGeom prst="rect">
             <a:avLst/>
@@ -1941,45 +2177,74 @@
               </a:spcAft>
             </a:pPr>
             <a:r>
-              <a:rPr lang="en-US" sz="2900" b="1">
-                <a:solidFill>
-                  <a:srgbClr val="F7F8F6"/>
-                </a:solidFill>
-              </a:rPr>
-              <a:t>3.</a:t>
-            </a:r>
-            <a:r>
-              <a:rPr lang="en-US" sz="2900" b="1">
-                <a:solidFill>
-                  <a:srgbClr val="4FA3A5"/>
-                </a:solidFill>
-              </a:rPr>
-              <a:t> Azure builds apps</a:t>
-            </a:r>
-          </a:p>
-        </p:txBody>
-      </p:sp>
-      <p:sp>
-        <p:nvSpPr>
-          <p:cNvPr id="4" name="Body"/>
-          <p:cNvSpPr txBox="1"/>
-          <p:nvPr/>
-        </p:nvSpPr>
-        <p:spPr>
-          <a:xfrm>
-            <a:off x="685800" y="1750000"/>
-            <a:ext cx="3900000" cy="3900000"/>
-          </a:xfrm>
-          <a:prstGeom prst="rect">
-            <a:avLst/>
-          </a:prstGeom>
-          <a:noFill/>
-          <a:ln>
-            <a:noFill/>
-          </a:ln>
-        </p:spPr>
-        <p:txBody>
-          <a:bodyPr wrap="square" lIns="182880" tIns="91440" rIns="182880" bIns="91440" anchor="t">
+              <a:rPr lang="en-US" sz="1100" b="1" cap="all" spc="120">
+                <a:solidFill>
+                  <a:srgbClr val="FFFFFF"/>
+                </a:solidFill>
+              </a:rPr>
+              <a:t>Microsoft</a:t>
+            </a:r>
+          </a:p>
+        </p:txBody>
+      </p:sp>
+      <p:sp>
+        <p:nvSpPr>
+          <p:cNvPr id="5" name="Slide number"/>
+          <p:cNvSpPr txBox="1"/>
+          <p:nvPr/>
+        </p:nvSpPr>
+        <p:spPr>
+          <a:xfrm>
+            <a:off x="9100000" y="0"/>
+            <a:ext cx="2406400" cy="502920"/>
+          </a:xfrm>
+          <a:prstGeom prst="rect">
+            <a:avLst/>
+          </a:prstGeom>
+          <a:noFill/>
+          <a:ln>
+            <a:noFill/>
+          </a:ln>
+        </p:spPr>
+        <p:txBody>
+          <a:bodyPr wrap="square" lIns="182880" tIns="91440" rIns="182880" bIns="91440" anchor="ctr">
+            <a:normAutofit/>
+          </a:bodyPr>
+          <a:lstStyle/>
+          <a:p>
+            <a:pPr algn="r"/>
+            <a:r>
+              <a:rPr lang="en-US" sz="1100" b="1" cap="all" spc="120">
+                <a:solidFill>
+                  <a:srgbClr val="BCBEC2"/>
+                </a:solidFill>
+              </a:rPr>
+              <a:t>4 / 6</a:t>
+            </a:r>
+          </a:p>
+        </p:txBody>
+      </p:sp>
+      <p:sp>
+        <p:nvSpPr>
+          <p:cNvPr id="6" name="Title"/>
+          <p:cNvSpPr txBox="1"/>
+          <p:nvPr/>
+        </p:nvSpPr>
+        <p:spPr>
+          <a:xfrm>
+            <a:off x="685800" y="700000"/>
+            <a:ext cx="10820400" cy="1150000"/>
+          </a:xfrm>
+          <a:prstGeom prst="rect">
+            <a:avLst/>
+          </a:prstGeom>
+          <a:noFill/>
+          <a:ln>
+            <a:noFill/>
+          </a:ln>
+        </p:spPr>
+        <p:txBody>
+          <a:bodyPr wrap="square" lIns="182880" tIns="91440" rIns="182880" bIns="91440" anchor="ctr">
             <a:normAutofit/>
           </a:bodyPr>
           <a:lstStyle/>
@@ -1993,77 +2258,36 @@
               </a:spcAft>
             </a:pPr>
             <a:r>
-              <a:rPr lang="en-US" sz="2500">
-                <a:solidFill>
-                  <a:srgbClr val="F7F8F6"/>
-                </a:solidFill>
-              </a:rPr>
-              <a:t>Use Azure when applications need cloud services: compute, storage, data and AI categories. It is the builder layer for apps and managed resources for teams.</a:t>
-            </a:r>
-          </a:p>
-        </p:txBody>
-      </p:sp>
-      <p:sp>
-        <p:nvSpPr>
-          <p:cNvPr id="5" name="Accent rule"/>
-          <p:cNvSpPr/>
-          <p:nvPr/>
-        </p:nvSpPr>
-        <p:spPr>
-          <a:xfrm>
-            <a:off x="548640" y="1800000"/>
-            <a:ext cx="45720" cy="3800000"/>
-          </a:xfrm>
-          <a:prstGeom prst="rect">
-            <a:avLst/>
-          </a:prstGeom>
-          <a:solidFill>
-            <a:srgbClr val="4FA3A5"/>
-          </a:solidFill>
-          <a:ln>
-            <a:noFill/>
-          </a:ln>
-        </p:spPr>
-      </p:sp>
-      <p:pic>
-        <p:nvPicPr>
-          <p:cNvPr id="6" name="Asset visual-azure-layer" descr="Azure is the cloud-services layer for application teams. (marp diagram)"/>
-          <p:cNvPicPr>
-            <a:picLocks noChangeAspect="1"/>
-          </p:cNvPicPr>
-          <p:nvPr/>
-        </p:nvPicPr>
-        <p:blipFill>
-          <a:blip r:embed="rIdImage1"/>
-          <a:stretch>
-            <a:fillRect/>
-          </a:stretch>
-        </p:blipFill>
-        <p:spPr>
-          <a:xfrm>
-            <a:off x="5000000" y="2021875"/>
-            <a:ext cx="6500000" cy="3656250"/>
-          </a:xfrm>
-          <a:prstGeom prst="rect">
-            <a:avLst/>
-          </a:prstGeom>
-          <a:ln>
-            <a:solidFill>
-              <a:srgbClr val="D9D9D9"/>
-            </a:solidFill>
-          </a:ln>
-        </p:spPr>
-      </p:pic>
-      <p:sp>
-        <p:nvSpPr>
-          <p:cNvPr id="7" name="Footer"/>
-          <p:cNvSpPr txBox="1"/>
-          <p:nvPr/>
-        </p:nvSpPr>
-        <p:spPr>
-          <a:xfrm>
-            <a:off x="685800" y="6250000"/>
-            <a:ext cx="9400000" cy="420000"/>
+              <a:rPr lang="en-US" sz="2900" b="1">
+                <a:solidFill>
+                  <a:srgbClr val="0B121E"/>
+                </a:solidFill>
+                <a:latin typeface="+mj-lt"/>
+              </a:rPr>
+              <a:t>3.</a:t>
+            </a:r>
+            <a:r>
+              <a:rPr lang="en-US" sz="2900" b="1">
+                <a:solidFill>
+                  <a:srgbClr val="006EC3"/>
+                </a:solidFill>
+                <a:latin typeface="+mj-lt"/>
+              </a:rPr>
+              <a:t> Azure builds apps</a:t>
+            </a:r>
+          </a:p>
+        </p:txBody>
+      </p:sp>
+      <p:sp>
+        <p:nvSpPr>
+          <p:cNvPr id="7" name="Body"/>
+          <p:cNvSpPr txBox="1"/>
+          <p:nvPr/>
+        </p:nvSpPr>
+        <p:spPr>
+          <a:xfrm>
+            <a:off x="685800" y="1950000"/>
+            <a:ext cx="3900000" cy="3900000"/>
           </a:xfrm>
           <a:prstGeom prst="rect">
             <a:avLst/>
@@ -2088,26 +2312,77 @@
               </a:spcAft>
             </a:pPr>
             <a:r>
-              <a:rPr lang="en-US" sz="1000">
-                <a:solidFill>
-                  <a:srgbClr val="B6B8B6"/>
-                </a:solidFill>
-              </a:rPr>
-              <a:t>Sources: Azure documentation | Microsoft Learn  ·  Windows 11 overview for administrators | Microsoft Learn  ·  Microsoft 365 for enterprise overview - Microsoft 365 Enterprise | Microsoft Learn  ·  +1 more</a:t>
-            </a:r>
-          </a:p>
-        </p:txBody>
-      </p:sp>
-      <p:sp>
-        <p:nvSpPr>
-          <p:cNvPr id="8" name="Slide number"/>
-          <p:cNvSpPr txBox="1"/>
-          <p:nvPr/>
-        </p:nvSpPr>
-        <p:spPr>
-          <a:xfrm>
-            <a:off x="10100000" y="6250000"/>
-            <a:ext cx="1400000" cy="420000"/>
+              <a:rPr lang="en-US" sz="2500">
+                <a:solidFill>
+                  <a:srgbClr val="0B121E"/>
+                </a:solidFill>
+              </a:rPr>
+              <a:t>Use Azure when applications need cloud services: compute, storage, data and AI categories. It is the builder layer for apps and managed resources for teams.</a:t>
+            </a:r>
+          </a:p>
+        </p:txBody>
+      </p:sp>
+      <p:sp>
+        <p:nvSpPr>
+          <p:cNvPr id="8" name="Accent rule"/>
+          <p:cNvSpPr/>
+          <p:nvPr/>
+        </p:nvSpPr>
+        <p:spPr>
+          <a:xfrm>
+            <a:off x="548640" y="2000000"/>
+            <a:ext cx="45720" cy="3800000"/>
+          </a:xfrm>
+          <a:prstGeom prst="rect">
+            <a:avLst/>
+          </a:prstGeom>
+          <a:solidFill>
+            <a:srgbClr val="006EC3"/>
+          </a:solidFill>
+          <a:ln>
+            <a:noFill/>
+          </a:ln>
+        </p:spPr>
+      </p:sp>
+      <p:pic>
+        <p:nvPicPr>
+          <p:cNvPr id="9" name="Asset visual-azure-layer" descr="Azure is the cloud-services layer for application teams. (marp diagram)"/>
+          <p:cNvPicPr>
+            <a:picLocks noChangeAspect="1"/>
+          </p:cNvPicPr>
+          <p:nvPr/>
+        </p:nvPicPr>
+        <p:blipFill>
+          <a:blip r:embed="rIdImage1"/>
+          <a:stretch>
+            <a:fillRect/>
+          </a:stretch>
+        </p:blipFill>
+        <p:spPr>
+          <a:xfrm>
+            <a:off x="5000000" y="2221875"/>
+            <a:ext cx="6500000" cy="3656250"/>
+          </a:xfrm>
+          <a:prstGeom prst="rect">
+            <a:avLst/>
+          </a:prstGeom>
+          <a:ln>
+            <a:solidFill>
+              <a:srgbClr val="D9D9D9"/>
+            </a:solidFill>
+          </a:ln>
+        </p:spPr>
+      </p:pic>
+      <p:sp>
+        <p:nvSpPr>
+          <p:cNvPr id="10" name="Footer"/>
+          <p:cNvSpPr txBox="1"/>
+          <p:nvPr/>
+        </p:nvSpPr>
+        <p:spPr>
+          <a:xfrm>
+            <a:off x="685800" y="6250000"/>
+            <a:ext cx="10820400" cy="420000"/>
           </a:xfrm>
           <a:prstGeom prst="rect">
             <a:avLst/>
@@ -2123,14 +2398,21 @@
           </a:bodyPr>
           <a:lstStyle/>
           <a:p>
-            <a:pPr algn="r"/>
+            <a:pPr algn="l">
+              <a:lnSpc>
+                <a:spcPct val="105000"/>
+              </a:lnSpc>
+              <a:spcAft>
+                <a:spcPts val="0"/>
+              </a:spcAft>
+            </a:pPr>
             <a:r>
               <a:rPr lang="en-US" sz="1000">
                 <a:solidFill>
-                  <a:srgbClr val="B6B8B6"/>
-                </a:solidFill>
-              </a:rPr>
-              <a:t>4 / 6</a:t>
+                  <a:srgbClr val="64686E"/>
+                </a:solidFill>
+              </a:rPr>
+              <a:t>Sources: Azure documentation | Microsoft Learn  ·  Windows 11 overview for administrators | Microsoft Learn  ·  Microsoft 365 for enterprise overview - Microsoft 365 Enterprise | Microsoft Learn  ·  +1 more</a:t>
             </a:r>
           </a:p>
         </p:txBody>
@@ -2149,7 +2431,7 @@
     <p:bg>
       <p:bgPr>
         <a:solidFill>
-          <a:srgbClr val="101313"/>
+          <a:srgbClr val="F4F8FC"/>
         </a:solidFill>
         <a:effectLst/>
       </p:bgPr>
@@ -2163,20 +2445,20 @@
       <p:grpSpPr/>
       <p:sp>
         <p:nvSpPr>
-          <p:cNvPr id="2" name="Accent band"/>
+          <p:cNvPr id="2" name="Brand band"/>
           <p:cNvSpPr/>
           <p:nvPr/>
         </p:nvSpPr>
         <p:spPr>
           <a:xfrm>
             <a:off x="0" y="0"/>
-            <a:ext cx="12192000" cy="91440"/>
+            <a:ext cx="12192000" cy="502920"/>
           </a:xfrm>
           <a:prstGeom prst="rect">
             <a:avLst/>
           </a:prstGeom>
           <a:solidFill>
-            <a:srgbClr val="4FA3A5"/>
+            <a:srgbClr val="0E1726"/>
           </a:solidFill>
           <a:ln>
             <a:noFill/>
@@ -2185,14 +2467,36 @@
       </p:sp>
       <p:sp>
         <p:nvSpPr>
-          <p:cNvPr id="3" name="Title"/>
-          <p:cNvSpPr txBox="1"/>
-          <p:nvPr/>
-        </p:nvSpPr>
-        <p:spPr>
-          <a:xfrm>
-            <a:off x="685800" y="420000"/>
-            <a:ext cx="10820400" cy="1150000"/>
+          <p:cNvPr id="3" name="Highlight rule"/>
+          <p:cNvSpPr/>
+          <p:nvPr/>
+        </p:nvSpPr>
+        <p:spPr>
+          <a:xfrm>
+            <a:off x="0" y="502920"/>
+            <a:ext cx="12192000" cy="45720"/>
+          </a:xfrm>
+          <a:prstGeom prst="rect">
+            <a:avLst/>
+          </a:prstGeom>
+          <a:solidFill>
+            <a:srgbClr val="8AC1EB"/>
+          </a:solidFill>
+          <a:ln>
+            <a:noFill/>
+          </a:ln>
+        </p:spPr>
+      </p:sp>
+      <p:sp>
+        <p:nvSpPr>
+          <p:cNvPr id="4" name="Deck kicker"/>
+          <p:cNvSpPr txBox="1"/>
+          <p:nvPr/>
+        </p:nvSpPr>
+        <p:spPr>
+          <a:xfrm>
+            <a:off x="685800" y="0"/>
+            <a:ext cx="8400000" cy="502920"/>
           </a:xfrm>
           <a:prstGeom prst="rect">
             <a:avLst/>
@@ -2217,45 +2521,74 @@
               </a:spcAft>
             </a:pPr>
             <a:r>
-              <a:rPr lang="en-US" sz="2900" b="1">
-                <a:solidFill>
-                  <a:srgbClr val="F7F8F6"/>
-                </a:solidFill>
-              </a:rPr>
-              <a:t>4.</a:t>
-            </a:r>
-            <a:r>
-              <a:rPr lang="en-US" sz="2900" b="1">
-                <a:solidFill>
-                  <a:srgbClr val="4FA3A5"/>
-                </a:solidFill>
-              </a:rPr>
-              <a:t> Copilot assists workflows</a:t>
-            </a:r>
-          </a:p>
-        </p:txBody>
-      </p:sp>
-      <p:sp>
-        <p:nvSpPr>
-          <p:cNvPr id="4" name="Body"/>
-          <p:cNvSpPr txBox="1"/>
-          <p:nvPr/>
-        </p:nvSpPr>
-        <p:spPr>
-          <a:xfrm>
-            <a:off x="685800" y="1750000"/>
-            <a:ext cx="3900000" cy="3900000"/>
-          </a:xfrm>
-          <a:prstGeom prst="rect">
-            <a:avLst/>
-          </a:prstGeom>
-          <a:noFill/>
-          <a:ln>
-            <a:noFill/>
-          </a:ln>
-        </p:spPr>
-        <p:txBody>
-          <a:bodyPr wrap="square" lIns="182880" tIns="91440" rIns="182880" bIns="91440" anchor="t">
+              <a:rPr lang="en-US" sz="1100" b="1" cap="all" spc="120">
+                <a:solidFill>
+                  <a:srgbClr val="FFFFFF"/>
+                </a:solidFill>
+              </a:rPr>
+              <a:t>Microsoft</a:t>
+            </a:r>
+          </a:p>
+        </p:txBody>
+      </p:sp>
+      <p:sp>
+        <p:nvSpPr>
+          <p:cNvPr id="5" name="Slide number"/>
+          <p:cNvSpPr txBox="1"/>
+          <p:nvPr/>
+        </p:nvSpPr>
+        <p:spPr>
+          <a:xfrm>
+            <a:off x="9100000" y="0"/>
+            <a:ext cx="2406400" cy="502920"/>
+          </a:xfrm>
+          <a:prstGeom prst="rect">
+            <a:avLst/>
+          </a:prstGeom>
+          <a:noFill/>
+          <a:ln>
+            <a:noFill/>
+          </a:ln>
+        </p:spPr>
+        <p:txBody>
+          <a:bodyPr wrap="square" lIns="182880" tIns="91440" rIns="182880" bIns="91440" anchor="ctr">
+            <a:normAutofit/>
+          </a:bodyPr>
+          <a:lstStyle/>
+          <a:p>
+            <a:pPr algn="r"/>
+            <a:r>
+              <a:rPr lang="en-US" sz="1100" b="1" cap="all" spc="120">
+                <a:solidFill>
+                  <a:srgbClr val="BCBEC2"/>
+                </a:solidFill>
+              </a:rPr>
+              <a:t>5 / 6</a:t>
+            </a:r>
+          </a:p>
+        </p:txBody>
+      </p:sp>
+      <p:sp>
+        <p:nvSpPr>
+          <p:cNvPr id="6" name="Title"/>
+          <p:cNvSpPr txBox="1"/>
+          <p:nvPr/>
+        </p:nvSpPr>
+        <p:spPr>
+          <a:xfrm>
+            <a:off x="685800" y="700000"/>
+            <a:ext cx="10820400" cy="1150000"/>
+          </a:xfrm>
+          <a:prstGeom prst="rect">
+            <a:avLst/>
+          </a:prstGeom>
+          <a:noFill/>
+          <a:ln>
+            <a:noFill/>
+          </a:ln>
+        </p:spPr>
+        <p:txBody>
+          <a:bodyPr wrap="square" lIns="182880" tIns="91440" rIns="182880" bIns="91440" anchor="ctr">
             <a:normAutofit/>
           </a:bodyPr>
           <a:lstStyle/>
@@ -2269,77 +2602,36 @@
               </a:spcAft>
             </a:pPr>
             <a:r>
-              <a:rPr lang="en-US" sz="2400">
-                <a:solidFill>
-                  <a:srgbClr val="F7F8F6"/>
-                </a:solidFill>
-              </a:rPr>
-              <a:t>Treat Copilot as AI assistance that sits inside selected workflows and licenses. Confirm access, grounding, service availability and subscription before commitments.</a:t>
-            </a:r>
-          </a:p>
-        </p:txBody>
-      </p:sp>
-      <p:sp>
-        <p:nvSpPr>
-          <p:cNvPr id="5" name="Accent rule"/>
-          <p:cNvSpPr/>
-          <p:nvPr/>
-        </p:nvSpPr>
-        <p:spPr>
-          <a:xfrm>
-            <a:off x="548640" y="1800000"/>
-            <a:ext cx="45720" cy="3800000"/>
-          </a:xfrm>
-          <a:prstGeom prst="rect">
-            <a:avLst/>
-          </a:prstGeom>
-          <a:solidFill>
-            <a:srgbClr val="4FA3A5"/>
-          </a:solidFill>
-          <a:ln>
-            <a:noFill/>
-          </a:ln>
-        </p:spPr>
-      </p:sp>
-      <p:pic>
-        <p:nvPicPr>
-          <p:cNvPr id="6" name="Asset visual-copilot-layer" descr="Copilot decisions need entitlement and grounding checks before commitments. (marp diagram)"/>
-          <p:cNvPicPr>
-            <a:picLocks noChangeAspect="1"/>
-          </p:cNvPicPr>
-          <p:nvPr/>
-        </p:nvPicPr>
-        <p:blipFill>
-          <a:blip r:embed="rIdImage1"/>
-          <a:stretch>
-            <a:fillRect/>
-          </a:stretch>
-        </p:blipFill>
-        <p:spPr>
-          <a:xfrm>
-            <a:off x="5000000" y="2021875"/>
-            <a:ext cx="6500000" cy="3656250"/>
-          </a:xfrm>
-          <a:prstGeom prst="rect">
-            <a:avLst/>
-          </a:prstGeom>
-          <a:ln>
-            <a:solidFill>
-              <a:srgbClr val="D9D9D9"/>
-            </a:solidFill>
-          </a:ln>
-        </p:spPr>
-      </p:pic>
-      <p:sp>
-        <p:nvSpPr>
-          <p:cNvPr id="7" name="Footer"/>
-          <p:cNvSpPr txBox="1"/>
-          <p:nvPr/>
-        </p:nvSpPr>
-        <p:spPr>
-          <a:xfrm>
-            <a:off x="685800" y="6250000"/>
-            <a:ext cx="9400000" cy="420000"/>
+              <a:rPr lang="en-US" sz="2900" b="1">
+                <a:solidFill>
+                  <a:srgbClr val="0B121E"/>
+                </a:solidFill>
+                <a:latin typeface="+mj-lt"/>
+              </a:rPr>
+              <a:t>4.</a:t>
+            </a:r>
+            <a:r>
+              <a:rPr lang="en-US" sz="2900" b="1">
+                <a:solidFill>
+                  <a:srgbClr val="006EC3"/>
+                </a:solidFill>
+                <a:latin typeface="+mj-lt"/>
+              </a:rPr>
+              <a:t> Copilot assists workflows</a:t>
+            </a:r>
+          </a:p>
+        </p:txBody>
+      </p:sp>
+      <p:sp>
+        <p:nvSpPr>
+          <p:cNvPr id="7" name="Body"/>
+          <p:cNvSpPr txBox="1"/>
+          <p:nvPr/>
+        </p:nvSpPr>
+        <p:spPr>
+          <a:xfrm>
+            <a:off x="685800" y="1950000"/>
+            <a:ext cx="3900000" cy="3900000"/>
           </a:xfrm>
           <a:prstGeom prst="rect">
             <a:avLst/>
@@ -2364,26 +2656,77 @@
               </a:spcAft>
             </a:pPr>
             <a:r>
-              <a:rPr lang="en-US" sz="1000">
-                <a:solidFill>
-                  <a:srgbClr val="B6B8B6"/>
-                </a:solidFill>
-              </a:rPr>
-              <a:t>Sources: Overview of Microsoft Copilot Chat | Microsoft Learn</a:t>
-            </a:r>
-          </a:p>
-        </p:txBody>
-      </p:sp>
-      <p:sp>
-        <p:nvSpPr>
-          <p:cNvPr id="8" name="Slide number"/>
-          <p:cNvSpPr txBox="1"/>
-          <p:nvPr/>
-        </p:nvSpPr>
-        <p:spPr>
-          <a:xfrm>
-            <a:off x="10100000" y="6250000"/>
-            <a:ext cx="1400000" cy="420000"/>
+              <a:rPr lang="en-US" sz="2400">
+                <a:solidFill>
+                  <a:srgbClr val="0B121E"/>
+                </a:solidFill>
+              </a:rPr>
+              <a:t>Treat Copilot as AI assistance that sits inside selected workflows and licenses. Confirm access, grounding, service availability and subscription before commitments.</a:t>
+            </a:r>
+          </a:p>
+        </p:txBody>
+      </p:sp>
+      <p:sp>
+        <p:nvSpPr>
+          <p:cNvPr id="8" name="Accent rule"/>
+          <p:cNvSpPr/>
+          <p:nvPr/>
+        </p:nvSpPr>
+        <p:spPr>
+          <a:xfrm>
+            <a:off x="548640" y="2000000"/>
+            <a:ext cx="45720" cy="3800000"/>
+          </a:xfrm>
+          <a:prstGeom prst="rect">
+            <a:avLst/>
+          </a:prstGeom>
+          <a:solidFill>
+            <a:srgbClr val="006EC3"/>
+          </a:solidFill>
+          <a:ln>
+            <a:noFill/>
+          </a:ln>
+        </p:spPr>
+      </p:sp>
+      <p:pic>
+        <p:nvPicPr>
+          <p:cNvPr id="9" name="Asset visual-copilot-layer" descr="Copilot decisions need entitlement and grounding checks before commitments. (marp diagram)"/>
+          <p:cNvPicPr>
+            <a:picLocks noChangeAspect="1"/>
+          </p:cNvPicPr>
+          <p:nvPr/>
+        </p:nvPicPr>
+        <p:blipFill>
+          <a:blip r:embed="rIdImage1"/>
+          <a:stretch>
+            <a:fillRect/>
+          </a:stretch>
+        </p:blipFill>
+        <p:spPr>
+          <a:xfrm>
+            <a:off x="5000000" y="2221875"/>
+            <a:ext cx="6500000" cy="3656250"/>
+          </a:xfrm>
+          <a:prstGeom prst="rect">
+            <a:avLst/>
+          </a:prstGeom>
+          <a:ln>
+            <a:solidFill>
+              <a:srgbClr val="D9D9D9"/>
+            </a:solidFill>
+          </a:ln>
+        </p:spPr>
+      </p:pic>
+      <p:sp>
+        <p:nvSpPr>
+          <p:cNvPr id="10" name="Footer"/>
+          <p:cNvSpPr txBox="1"/>
+          <p:nvPr/>
+        </p:nvSpPr>
+        <p:spPr>
+          <a:xfrm>
+            <a:off x="685800" y="6250000"/>
+            <a:ext cx="10820400" cy="420000"/>
           </a:xfrm>
           <a:prstGeom prst="rect">
             <a:avLst/>
@@ -2399,14 +2742,21 @@
           </a:bodyPr>
           <a:lstStyle/>
           <a:p>
-            <a:pPr algn="r"/>
+            <a:pPr algn="l">
+              <a:lnSpc>
+                <a:spcPct val="105000"/>
+              </a:lnSpc>
+              <a:spcAft>
+                <a:spcPts val="0"/>
+              </a:spcAft>
+            </a:pPr>
             <a:r>
               <a:rPr lang="en-US" sz="1000">
                 <a:solidFill>
-                  <a:srgbClr val="B6B8B6"/>
-                </a:solidFill>
-              </a:rPr>
-              <a:t>5 / 6</a:t>
+                  <a:srgbClr val="64686E"/>
+                </a:solidFill>
+              </a:rPr>
+              <a:t>Sources: Overview of Microsoft Copilot Chat | Microsoft Learn</a:t>
             </a:r>
           </a:p>
         </p:txBody>
@@ -2425,7 +2775,7 @@
     <p:bg>
       <p:bgPr>
         <a:solidFill>
-          <a:srgbClr val="101313"/>
+          <a:srgbClr val="F4F8FC"/>
         </a:solidFill>
         <a:effectLst/>
       </p:bgPr>
@@ -2439,20 +2789,20 @@
       <p:grpSpPr/>
       <p:sp>
         <p:nvSpPr>
-          <p:cNvPr id="2" name="Accent band"/>
+          <p:cNvPr id="2" name="Brand band"/>
           <p:cNvSpPr/>
           <p:nvPr/>
         </p:nvSpPr>
         <p:spPr>
           <a:xfrm>
             <a:off x="0" y="0"/>
-            <a:ext cx="12192000" cy="91440"/>
+            <a:ext cx="12192000" cy="502920"/>
           </a:xfrm>
           <a:prstGeom prst="rect">
             <a:avLst/>
           </a:prstGeom>
           <a:solidFill>
-            <a:srgbClr val="4FA3A5"/>
+            <a:srgbClr val="0E1726"/>
           </a:solidFill>
           <a:ln>
             <a:noFill/>
@@ -2461,14 +2811,36 @@
       </p:sp>
       <p:sp>
         <p:nvSpPr>
-          <p:cNvPr id="3" name="Title"/>
-          <p:cNvSpPr txBox="1"/>
-          <p:nvPr/>
-        </p:nvSpPr>
-        <p:spPr>
-          <a:xfrm>
-            <a:off x="685800" y="420000"/>
-            <a:ext cx="10820400" cy="1000000"/>
+          <p:cNvPr id="3" name="Highlight rule"/>
+          <p:cNvSpPr/>
+          <p:nvPr/>
+        </p:nvSpPr>
+        <p:spPr>
+          <a:xfrm>
+            <a:off x="0" y="502920"/>
+            <a:ext cx="12192000" cy="45720"/>
+          </a:xfrm>
+          <a:prstGeom prst="rect">
+            <a:avLst/>
+          </a:prstGeom>
+          <a:solidFill>
+            <a:srgbClr val="8AC1EB"/>
+          </a:solidFill>
+          <a:ln>
+            <a:noFill/>
+          </a:ln>
+        </p:spPr>
+      </p:sp>
+      <p:sp>
+        <p:nvSpPr>
+          <p:cNvPr id="4" name="Deck kicker"/>
+          <p:cNvSpPr txBox="1"/>
+          <p:nvPr/>
+        </p:nvSpPr>
+        <p:spPr>
+          <a:xfrm>
+            <a:off x="685800" y="0"/>
+            <a:ext cx="8400000" cy="502920"/>
           </a:xfrm>
           <a:prstGeom prst="rect">
             <a:avLst/>
@@ -2493,45 +2865,74 @@
               </a:spcAft>
             </a:pPr>
             <a:r>
-              <a:rPr lang="en-US" sz="2400" b="1">
-                <a:solidFill>
-                  <a:srgbClr val="F7F8F6"/>
-                </a:solidFill>
-              </a:rPr>
-              <a:t>Sources.</a:t>
-            </a:r>
-            <a:r>
-              <a:rPr lang="en-US" sz="2400" b="1">
-                <a:solidFill>
-                  <a:srgbClr val="4FA3A5"/>
-                </a:solidFill>
-              </a:rPr>
-              <a:t> Every claim traces to one.</a:t>
-            </a:r>
-          </a:p>
-        </p:txBody>
-      </p:sp>
-      <p:sp>
-        <p:nvSpPr>
-          <p:cNvPr id="4" name="Sources"/>
-          <p:cNvSpPr txBox="1"/>
-          <p:nvPr/>
-        </p:nvSpPr>
-        <p:spPr>
-          <a:xfrm>
-            <a:off x="685800" y="1700000"/>
-            <a:ext cx="10820400" cy="4300000"/>
-          </a:xfrm>
-          <a:prstGeom prst="rect">
-            <a:avLst/>
-          </a:prstGeom>
-          <a:noFill/>
-          <a:ln>
-            <a:noFill/>
-          </a:ln>
-        </p:spPr>
-        <p:txBody>
-          <a:bodyPr wrap="square" lIns="182880" tIns="91440" rIns="182880" bIns="91440" anchor="t">
+              <a:rPr lang="en-US" sz="1100" b="1" cap="all" spc="120">
+                <a:solidFill>
+                  <a:srgbClr val="FFFFFF"/>
+                </a:solidFill>
+              </a:rPr>
+              <a:t>Microsoft</a:t>
+            </a:r>
+          </a:p>
+        </p:txBody>
+      </p:sp>
+      <p:sp>
+        <p:nvSpPr>
+          <p:cNvPr id="5" name="Slide number"/>
+          <p:cNvSpPr txBox="1"/>
+          <p:nvPr/>
+        </p:nvSpPr>
+        <p:spPr>
+          <a:xfrm>
+            <a:off x="9100000" y="0"/>
+            <a:ext cx="2406400" cy="502920"/>
+          </a:xfrm>
+          <a:prstGeom prst="rect">
+            <a:avLst/>
+          </a:prstGeom>
+          <a:noFill/>
+          <a:ln>
+            <a:noFill/>
+          </a:ln>
+        </p:spPr>
+        <p:txBody>
+          <a:bodyPr wrap="square" lIns="182880" tIns="91440" rIns="182880" bIns="91440" anchor="ctr">
+            <a:normAutofit/>
+          </a:bodyPr>
+          <a:lstStyle/>
+          <a:p>
+            <a:pPr algn="r"/>
+            <a:r>
+              <a:rPr lang="en-US" sz="1100" b="1" cap="all" spc="120">
+                <a:solidFill>
+                  <a:srgbClr val="BCBEC2"/>
+                </a:solidFill>
+              </a:rPr>
+              <a:t>6 / 6</a:t>
+            </a:r>
+          </a:p>
+        </p:txBody>
+      </p:sp>
+      <p:sp>
+        <p:nvSpPr>
+          <p:cNvPr id="6" name="Title"/>
+          <p:cNvSpPr txBox="1"/>
+          <p:nvPr/>
+        </p:nvSpPr>
+        <p:spPr>
+          <a:xfrm>
+            <a:off x="685800" y="760000"/>
+            <a:ext cx="10820400" cy="1000000"/>
+          </a:xfrm>
+          <a:prstGeom prst="rect">
+            <a:avLst/>
+          </a:prstGeom>
+          <a:noFill/>
+          <a:ln>
+            <a:noFill/>
+          </a:ln>
+        </p:spPr>
+        <p:txBody>
+          <a:bodyPr wrap="square" lIns="182880" tIns="91440" rIns="182880" bIns="91440" anchor="ctr">
             <a:normAutofit/>
           </a:bodyPr>
           <a:lstStyle/>
@@ -2545,9 +2946,63 @@
               </a:spcAft>
             </a:pPr>
             <a:r>
+              <a:rPr lang="en-US" sz="2400" b="1">
+                <a:solidFill>
+                  <a:srgbClr val="0B121E"/>
+                </a:solidFill>
+                <a:latin typeface="+mj-lt"/>
+              </a:rPr>
+              <a:t>Sources.</a:t>
+            </a:r>
+            <a:r>
+              <a:rPr lang="en-US" sz="2400" b="1">
+                <a:solidFill>
+                  <a:srgbClr val="006EC3"/>
+                </a:solidFill>
+                <a:latin typeface="+mj-lt"/>
+              </a:rPr>
+              <a:t> Every claim traces to one.</a:t>
+            </a:r>
+          </a:p>
+        </p:txBody>
+      </p:sp>
+      <p:sp>
+        <p:nvSpPr>
+          <p:cNvPr id="7" name="Sources"/>
+          <p:cNvSpPr txBox="1"/>
+          <p:nvPr/>
+        </p:nvSpPr>
+        <p:spPr>
+          <a:xfrm>
+            <a:off x="685800" y="1900000"/>
+            <a:ext cx="10820400" cy="4300000"/>
+          </a:xfrm>
+          <a:prstGeom prst="rect">
+            <a:avLst/>
+          </a:prstGeom>
+          <a:noFill/>
+          <a:ln>
+            <a:noFill/>
+          </a:ln>
+        </p:spPr>
+        <p:txBody>
+          <a:bodyPr wrap="square" lIns="182880" tIns="91440" rIns="182880" bIns="91440" anchor="t">
+            <a:normAutofit/>
+          </a:bodyPr>
+          <a:lstStyle/>
+          <a:p>
+            <a:pPr algn="l">
+              <a:lnSpc>
+                <a:spcPct val="105000"/>
+              </a:lnSpc>
+              <a:spcAft>
+                <a:spcPts val="0"/>
+              </a:spcAft>
+            </a:pPr>
+            <a:r>
               <a:rPr lang="en-US" sz="1400" b="1">
                 <a:solidFill>
-                  <a:srgbClr val="F7F8F6"/>
+                  <a:srgbClr val="0B121E"/>
                 </a:solidFill>
               </a:rPr>
               <a:t>Windows 11 overview for administrators | Microsoft Learn</a:t>
@@ -2555,7 +3010,7 @@
             <a:r>
               <a:rPr lang="en-US" sz="1100">
                 <a:solidFill>
-                  <a:srgbClr val="B6B8B6"/>
+                  <a:srgbClr val="64686E"/>
                 </a:solidFill>
               </a:rPr>
               <a:t>  retrieved 2026-10-06</a:t>
@@ -2573,7 +3028,7 @@
             <a:r>
               <a:rPr lang="en-US" sz="1100">
                 <a:solidFill>
-                  <a:srgbClr val="4FA3A5"/>
+                  <a:srgbClr val="006EC3"/>
                 </a:solidFill>
               </a:rPr>
               <a:t>https://learn.microsoft.com/en-us/windows/whats-new/windows-11-overview</a:t>
@@ -2591,7 +3046,7 @@
             <a:r>
               <a:rPr lang="en-US" sz="1400" b="1">
                 <a:solidFill>
-                  <a:srgbClr val="F7F8F6"/>
+                  <a:srgbClr val="0B121E"/>
                 </a:solidFill>
               </a:rPr>
               <a:t>Microsoft 365 for enterprise overview - Microsoft 365 Enterprise | Microsoft Learn</a:t>
@@ -2599,7 +3054,7 @@
             <a:r>
               <a:rPr lang="en-US" sz="1100">
                 <a:solidFill>
-                  <a:srgbClr val="B6B8B6"/>
+                  <a:srgbClr val="64686E"/>
                 </a:solidFill>
               </a:rPr>
               <a:t>  retrieved 2026-10-06</a:t>
@@ -2617,7 +3072,7 @@
             <a:r>
               <a:rPr lang="en-US" sz="1100">
                 <a:solidFill>
-                  <a:srgbClr val="4FA3A5"/>
+                  <a:srgbClr val="006EC3"/>
                 </a:solidFill>
               </a:rPr>
               <a:t>https://learn.microsoft.com/en-us/microsoft-365/enterprise/microsoft-365-overview?view=o365-worldwide</a:t>
@@ -2635,7 +3090,7 @@
             <a:r>
               <a:rPr lang="en-US" sz="1400" b="1">
                 <a:solidFill>
-                  <a:srgbClr val="F7F8F6"/>
+                  <a:srgbClr val="0B121E"/>
                 </a:solidFill>
               </a:rPr>
               <a:t>Azure documentation | Microsoft Learn</a:t>
@@ -2643,7 +3098,7 @@
             <a:r>
               <a:rPr lang="en-US" sz="1100">
                 <a:solidFill>
-                  <a:srgbClr val="B6B8B6"/>
+                  <a:srgbClr val="64686E"/>
                 </a:solidFill>
               </a:rPr>
               <a:t>  retrieved 2026-10-06</a:t>
@@ -2661,7 +3116,7 @@
             <a:r>
               <a:rPr lang="en-US" sz="1100">
                 <a:solidFill>
-                  <a:srgbClr val="4FA3A5"/>
+                  <a:srgbClr val="006EC3"/>
                 </a:solidFill>
               </a:rPr>
               <a:t>https://learn.microsoft.com/en-us/azure/</a:t>
@@ -2679,7 +3134,7 @@
             <a:r>
               <a:rPr lang="en-US" sz="1400" b="1">
                 <a:solidFill>
-                  <a:srgbClr val="F7F8F6"/>
+                  <a:srgbClr val="0B121E"/>
                 </a:solidFill>
               </a:rPr>
               <a:t>Overview of Microsoft Copilot Chat | Microsoft Learn</a:t>
@@ -2687,7 +3142,7 @@
             <a:r>
               <a:rPr lang="en-US" sz="1100">
                 <a:solidFill>
-                  <a:srgbClr val="B6B8B6"/>
+                  <a:srgbClr val="64686E"/>
                 </a:solidFill>
               </a:rPr>
               <a:t>  retrieved 2026-10-06</a:t>
@@ -2705,7 +3160,7 @@
             <a:r>
               <a:rPr lang="en-US" sz="1100">
                 <a:solidFill>
-                  <a:srgbClr val="4FA3A5"/>
+                  <a:srgbClr val="006EC3"/>
                 </a:solidFill>
               </a:rPr>
               <a:t>https://learn.microsoft.com/en-us/copilot/overview</a:t>
@@ -2715,14 +3170,14 @@
       </p:sp>
       <p:sp>
         <p:nvSpPr>
-          <p:cNvPr id="5" name="Footer"/>
+          <p:cNvPr id="8" name="Footer"/>
           <p:cNvSpPr txBox="1"/>
           <p:nvPr/>
         </p:nvSpPr>
         <p:spPr>
           <a:xfrm>
             <a:off x="685800" y="6250000"/>
-            <a:ext cx="9400000" cy="420000"/>
+            <a:ext cx="10820400" cy="420000"/>
           </a:xfrm>
           <a:prstGeom prst="rect">
             <a:avLst/>
@@ -2749,47 +3204,10 @@
             <a:r>
               <a:rPr lang="en-US" sz="1000">
                 <a:solidFill>
-                  <a:srgbClr val="B6B8B6"/>
-                </a:solidFill>
-              </a:rPr>
-              <a:t>microsoft-2026-05-am-michael-kokoro-onnx</a:t>
-            </a:r>
-          </a:p>
-        </p:txBody>
-      </p:sp>
-      <p:sp>
-        <p:nvSpPr>
-          <p:cNvPr id="6" name="Slide number"/>
-          <p:cNvSpPr txBox="1"/>
-          <p:nvPr/>
-        </p:nvSpPr>
-        <p:spPr>
-          <a:xfrm>
-            <a:off x="10100000" y="6250000"/>
-            <a:ext cx="1400000" cy="420000"/>
-          </a:xfrm>
-          <a:prstGeom prst="rect">
-            <a:avLst/>
-          </a:prstGeom>
-          <a:noFill/>
-          <a:ln>
-            <a:noFill/>
-          </a:ln>
-        </p:spPr>
-        <p:txBody>
-          <a:bodyPr wrap="square" lIns="182880" tIns="91440" rIns="182880" bIns="91440" anchor="t">
-            <a:normAutofit/>
-          </a:bodyPr>
-          <a:lstStyle/>
-          <a:p>
-            <a:pPr algn="r"/>
-            <a:r>
-              <a:rPr lang="en-US" sz="1000">
-                <a:solidFill>
-                  <a:srgbClr val="B6B8B6"/>
-                </a:solidFill>
-              </a:rPr>
-              <a:t>6 / 6</a:t>
+                  <a:srgbClr val="64686E"/>
+                </a:solidFill>
+              </a:rPr>
+              <a:t>microsoft-2026-06-am-michael-kokoro-onnx</a:t>
             </a:r>
           </a:p>
         </p:txBody>
@@ -2803,59 +3221,59 @@
 </file>
 
 <file path=ppt/theme/theme1.xml><?xml version="1.0" encoding="utf-8"?>
-<a:theme xmlns:a="http://schemas.openxmlformats.org/drawingml/2006/main" name="executive-dark-teal">
+<a:theme xmlns:a="http://schemas.openxmlformats.org/drawingml/2006/main" name="microsoft-brand">
   <a:themeElements>
-    <a:clrScheme name="executive-dark-teal">
+    <a:clrScheme name="microsoft-brand">
       <a:dk1>
-        <a:srgbClr val="F7F8F6"/>
+        <a:srgbClr val="0B121E"/>
       </a:dk1>
       <a:lt1>
-        <a:srgbClr val="101313"/>
+        <a:srgbClr val="F4F8FC"/>
       </a:lt1>
       <a:dk2>
-        <a:srgbClr val="1F1F1F"/>
+        <a:srgbClr val="0E1726"/>
       </a:dk2>
       <a:lt2>
-        <a:srgbClr val="F8F8F8"/>
+        <a:srgbClr val="E6F1F9"/>
       </a:lt2>
       <a:accent1>
-        <a:srgbClr val="4FA3A5"/>
+        <a:srgbClr val="006EC3"/>
       </a:accent1>
       <a:accent2>
-        <a:srgbClr val="5B9BD5"/>
+        <a:srgbClr val="8AC1EB"/>
       </a:accent2>
       <a:accent3>
-        <a:srgbClr val="70AD47"/>
+        <a:srgbClr val="006EC3"/>
       </a:accent3>
       <a:accent4>
-        <a:srgbClr val="FFC000"/>
+        <a:srgbClr val="090F19"/>
       </a:accent4>
       <a:accent5>
-        <a:srgbClr val="C00000"/>
+        <a:srgbClr val="64686E"/>
       </a:accent5>
       <a:accent6>
-        <a:srgbClr val="7030A0"/>
+        <a:srgbClr val="B42318"/>
       </a:accent6>
       <a:hlink>
-        <a:srgbClr val="4FA3A5"/>
+        <a:srgbClr val="006EC3"/>
       </a:hlink>
       <a:folHlink>
-        <a:srgbClr val="7F7F7F"/>
+        <a:srgbClr val="64686E"/>
       </a:folHlink>
     </a:clrScheme>
-    <a:fontScheme name="executive-dark-teal">
+    <a:fontScheme name="microsoft-brand">
       <a:majorFont>
-        <a:latin typeface="Arial"/>
+        <a:latin typeface="Segoe UI Variable Display"/>
         <a:ea typeface=""/>
         <a:cs typeface=""/>
       </a:majorFont>
       <a:minorFont>
-        <a:latin typeface="Arial"/>
+        <a:latin typeface="Segoe UI"/>
         <a:ea typeface=""/>
         <a:cs typeface=""/>
       </a:minorFont>
     </a:fontScheme>
-    <a:fmtScheme name="executive-dark-teal">
+    <a:fmtScheme name="microsoft-brand">
       <a:fillStyleLst>
         <a:solidFill>
           <a:schemeClr val="phClr"/>

</xml_diff>

<commit_message>
feat: regenerate microsoft on media adapter 13
- render four voices with source-seeded Excalidraw strokes
- add video and spatial spectrograms and internal/external alignment evidence

🎨 - Generated by Copilot

Co-authored-by: Copilot <223556219+Copilot@users.noreply.github.com>
</commit_message>
<xml_diff>
--- a/projects/microsoft/release/outputs/deck.pptx
+++ b/projects/microsoft/release/outputs/deck.pptx
@@ -1380,7 +1380,7 @@
                   <a:srgbClr val="64686E"/>
                 </a:solidFill>
               </a:rPr>
-              <a:t>microsoft-2026-06-am-michael-kokoro-onnx</a:t>
+              <a:t>microsoft-2026-07-am-michael-kokoro-onnx</a:t>
             </a:r>
           </a:p>
         </p:txBody>
@@ -3207,7 +3207,7 @@
                   <a:srgbClr val="64686E"/>
                 </a:solidFill>
               </a:rPr>
-              <a:t>microsoft-2026-06-am-michael-kokoro-onnx</a:t>
+              <a:t>microsoft-2026-07-am-michael-kokoro-onnx</a:t>
             </a:r>
           </a:p>
         </p:txBody>

</xml_diff>